<commit_message>
Replace sample deal with an Indian company
</commit_message>
<xml_diff>
--- a/sample_deal/management_deck.pptx
+++ b/sample_deal/management_deck.pptx
@@ -3106,7 +3106,7 @@
           <a:lstStyle/>
           <a:p>
             <a:r>
-              <a:t>Halden Precision Components</a:t>
+              <a:t>Nilgiri Precision Components Limited</a:t>
             </a:r>
           </a:p>
         </p:txBody>
@@ -3190,27 +3190,18 @@
                 <a:tableStyleId>{5C22544A-7EE6-4342-B048-85BDC9FD1C3A}</a:tableStyleId>
               </a:tblPr>
               <a:tblGrid>
-                <a:gridCol w="1965960"/>
-                <a:gridCol w="1965960"/>
-                <a:gridCol w="1965960"/>
-                <a:gridCol w="1965960"/>
+                <a:gridCol w="2621280"/>
+                <a:gridCol w="2621280"/>
+                <a:gridCol w="2621280"/>
               </a:tblGrid>
-              <a:tr h="475488">
-                <a:tc>
-                  <a:txBody>
-                    <a:bodyPr/>
-                    <a:lstStyle/>
-                    <a:p/>
-                  </a:txBody>
-                  <a:tcPr/>
-                </a:tc>
+              <a:tr h="396240">
                 <a:tc>
                   <a:txBody>
                     <a:bodyPr/>
                     <a:lstStyle/>
                     <a:p>
                       <a:r>
-                        <a:t>FY2022</a:t>
+                        <a:t>Particulars (₹ Cr)</a:t>
                       </a:r>
                     </a:p>
                   </a:txBody>
@@ -3222,7 +3213,7 @@
                     <a:lstStyle/>
                     <a:p>
                       <a:r>
-                        <a:t>FY2023</a:t>
+                        <a:t>FY23</a:t>
                       </a:r>
                     </a:p>
                   </a:txBody>
@@ -3234,21 +3225,21 @@
                     <a:lstStyle/>
                     <a:p>
                       <a:r>
-                        <a:t>FY2024</a:t>
+                        <a:t>FY24</a:t>
                       </a:r>
                     </a:p>
                   </a:txBody>
                   <a:tcPr/>
                 </a:tc>
               </a:tr>
-              <a:tr h="475488">
+              <a:tr h="396240">
                 <a:tc>
                   <a:txBody>
                     <a:bodyPr/>
                     <a:lstStyle/>
                     <a:p>
                       <a:r>
-                        <a:t>Revenue ($M)</a:t>
+                        <a:t>Revenue</a:t>
                       </a:r>
                     </a:p>
                   </a:txBody>
@@ -3260,7 +3251,7 @@
                     <a:lstStyle/>
                     <a:p>
                       <a:r>
-                        <a:t>86.2</a:t>
+                        <a:t>822.1</a:t>
                       </a:r>
                     </a:p>
                   </a:txBody>
@@ -3272,7 +3263,21 @@
                     <a:lstStyle/>
                     <a:p>
                       <a:r>
-                        <a:t>90.9</a:t>
+                        <a:t>888.3</a:t>
+                      </a:r>
+                    </a:p>
+                  </a:txBody>
+                  <a:tcPr/>
+                </a:tc>
+              </a:tr>
+              <a:tr h="396240">
+                <a:tc>
+                  <a:txBody>
+                    <a:bodyPr/>
+                    <a:lstStyle/>
+                    <a:p>
+                      <a:r>
+                        <a:t>EBITDA</a:t>
                       </a:r>
                     </a:p>
                   </a:txBody>
@@ -3284,21 +3289,7 @@
                     <a:lstStyle/>
                     <a:p>
                       <a:r>
-                        <a:t>100.5</a:t>
-                      </a:r>
-                    </a:p>
-                  </a:txBody>
-                  <a:tcPr/>
-                </a:tc>
-              </a:tr>
-              <a:tr h="475488">
-                <a:tc>
-                  <a:txBody>
-                    <a:bodyPr/>
-                    <a:lstStyle/>
-                    <a:p>
-                      <a:r>
-                        <a:t>EBITDA ($M)</a:t>
+                        <a:t>105.4</a:t>
                       </a:r>
                     </a:p>
                   </a:txBody>
@@ -3310,38 +3301,14 @@
                     <a:lstStyle/>
                     <a:p>
                       <a:r>
-                        <a:t>12.0</a:t>
-                      </a:r>
-                    </a:p>
-                  </a:txBody>
-                  <a:tcPr/>
-                </a:tc>
-                <a:tc>
-                  <a:txBody>
-                    <a:bodyPr/>
-                    <a:lstStyle/>
-                    <a:p>
-                      <a:r>
-                        <a:t>13.3</a:t>
-                      </a:r>
-                    </a:p>
-                  </a:txBody>
-                  <a:tcPr/>
-                </a:tc>
-                <a:tc>
-                  <a:txBody>
-                    <a:bodyPr/>
-                    <a:lstStyle/>
-                    <a:p>
-                      <a:r>
-                        <a:t>17.3</a:t>
+                        <a:t>123.4</a:t>
                       </a:r>
                     </a:p>
                   </a:txBody>
                   <a:tcPr/>
                 </a:tc>
               </a:tr>
-              <a:tr h="475488">
+              <a:tr h="396240">
                 <a:tc>
                   <a:txBody>
                     <a:bodyPr/>
@@ -3360,7 +3327,7 @@
                     <a:lstStyle/>
                     <a:p>
                       <a:r>
-                        <a:t>13.9</a:t>
+                        <a:t>12.8</a:t>
                       </a:r>
                     </a:p>
                   </a:txBody>
@@ -3372,26 +3339,14 @@
                     <a:lstStyle/>
                     <a:p>
                       <a:r>
-                        <a:t>14.6</a:t>
-                      </a:r>
-                    </a:p>
-                  </a:txBody>
-                  <a:tcPr/>
-                </a:tc>
-                <a:tc>
-                  <a:txBody>
-                    <a:bodyPr/>
-                    <a:lstStyle/>
-                    <a:p>
-                      <a:r>
-                        <a:t>17.2</a:t>
+                        <a:t>13.9</a:t>
                       </a:r>
                     </a:p>
                   </a:txBody>
                   <a:tcPr/>
                 </a:tc>
               </a:tr>
-              <a:tr h="475488">
+              <a:tr h="396240">
                 <a:tc>
                   <a:txBody>
                     <a:bodyPr/>
@@ -3410,7 +3365,7 @@
                     <a:lstStyle/>
                     <a:p>
                       <a:r>
-                        <a:t>36.2</a:t>
+                        <a:t>40.2</a:t>
                       </a:r>
                     </a:p>
                   </a:txBody>
@@ -3422,7 +3377,21 @@
                     <a:lstStyle/>
                     <a:p>
                       <a:r>
-                        <a:t>35.5</a:t>
+                        <a:t>39.8</a:t>
+                      </a:r>
+                    </a:p>
+                  </a:txBody>
+                  <a:tcPr/>
+                </a:tc>
+              </a:tr>
+              <a:tr h="396240">
+                <a:tc>
+                  <a:txBody>
+                    <a:bodyPr/>
+                    <a:lstStyle/>
+                    <a:p>
+                      <a:r>
+                        <a:t>PAT</a:t>
                       </a:r>
                     </a:p>
                   </a:txBody>
@@ -3434,7 +3403,19 @@
                     <a:lstStyle/>
                     <a:p>
                       <a:r>
-                        <a:t>40.0</a:t>
+                        <a:t>52.6</a:t>
+                      </a:r>
+                    </a:p>
+                  </a:txBody>
+                  <a:tcPr/>
+                </a:tc>
+                <a:tc>
+                  <a:txBody>
+                    <a:bodyPr/>
+                    <a:lstStyle/>
+                    <a:p>
+                      <a:r>
+                        <a:t>46.7</a:t>
                       </a:r>
                     </a:p>
                   </a:txBody>
@@ -3479,7 +3460,7 @@
           <a:lstStyle/>
           <a:p>
             <a:r>
-              <a:t>Balance sheet and customers</a:t>
+              <a:t>Balance sheet, customers and order book</a:t>
             </a:r>
           </a:p>
         </p:txBody>
@@ -3507,22 +3488,22 @@
           <a:lstStyle/>
           <a:p>
             <a:r>
-              <a:t>Net debt (FY2024): $21.4M</a:t>
-            </a:r>
-          </a:p>
-          <a:p>
-            <a:r>
-              <a:t>Cash (FY2024): $6.5M</a:t>
-            </a:r>
-          </a:p>
-          <a:p>
-            <a:r>
-              <a:t>Top customer: 19% of FY2024 revenue</a:t>
-            </a:r>
-          </a:p>
-          <a:p>
-            <a:r>
-              <a:t>ARR (FY2024): $37.1M</a:t>
+              <a:t>Net debt (FY24): ₹92.8 Cr</a:t>
+            </a:r>
+          </a:p>
+          <a:p>
+            <a:r>
+              <a:t>Cash (FY24): ₹34.4 Cr</a:t>
+            </a:r>
+          </a:p>
+          <a:p>
+            <a:r>
+              <a:t>Top customer: 16% of FY24 revenue</a:t>
+            </a:r>
+          </a:p>
+          <a:p>
+            <a:r>
+              <a:t>Order book (FY24): ₹796.3 Cr</a:t>
             </a:r>
           </a:p>
         </p:txBody>

</xml_diff>

<commit_message>
Sample deal regenerated with footnote cases
</commit_message>
<xml_diff>
--- a/sample_deal/management_deck.pptx
+++ b/sample_deal/management_deck.pptx
@@ -3277,7 +3277,7 @@
                     <a:lstStyle/>
                     <a:p>
                       <a:r>
-                        <a:t>EBITDA</a:t>
+                        <a:t>EBITDA †</a:t>
                       </a:r>
                     </a:p>
                   </a:txBody>
@@ -3301,7 +3301,7 @@
                     <a:lstStyle/>
                     <a:p>
                       <a:r>
-                        <a:t>123.4</a:t>
+                        <a:t>121.6</a:t>
                       </a:r>
                     </a:p>
                   </a:txBody>
@@ -3339,7 +3339,7 @@
                     <a:lstStyle/>
                     <a:p>
                       <a:r>
-                        <a:t>13.9</a:t>
+                        <a:t>13.7</a:t>
                       </a:r>
                     </a:p>
                   </a:txBody>
@@ -3377,7 +3377,7 @@
                     <a:lstStyle/>
                     <a:p>
                       <a:r>
-                        <a:t>39.8</a:t>
+                        <a:t>44.5</a:t>
                       </a:r>
                     </a:p>
                   </a:txBody>
@@ -3426,6 +3426,39 @@
           </a:graphicData>
         </a:graphic>
       </p:graphicFrame>
+      <p:sp>
+        <p:nvSpPr>
+          <p:cNvPr id="4" name="TextBox 3"/>
+          <p:cNvSpPr txBox="1"/>
+          <p:nvPr/>
+        </p:nvSpPr>
+        <p:spPr>
+          <a:xfrm>
+            <a:off x="640080" y="4297680"/>
+            <a:ext cx="7863840" cy="914400"/>
+          </a:xfrm>
+          <a:prstGeom prst="rect">
+            <a:avLst/>
+          </a:prstGeom>
+          <a:noFill/>
+        </p:spPr>
+        <p:txBody>
+          <a:bodyPr wrap="none">
+            <a:spAutoFit/>
+          </a:bodyPr>
+          <a:lstStyle/>
+          <a:p>
+            <a:r>
+              <a:t>† Adjusted EBITDA; excludes exceptional items of ₹5.2 Cr.</a:t>
+            </a:r>
+          </a:p>
+          <a:p>
+            <a:r>
+              <a:t>Source: Audited financial statements; figures rounded to one decimal.</a:t>
+            </a:r>
+          </a:p>
+        </p:txBody>
+      </p:sp>
     </p:spTree>
   </p:cSld>
   <p:clrMapOvr>
@@ -3488,7 +3521,7 @@
           <a:lstStyle/>
           <a:p>
             <a:r>
-              <a:t>Net debt (FY24): ₹92.8 Cr</a:t>
+              <a:t>Net debt (FY24): ₹171.5 Cr</a:t>
             </a:r>
           </a:p>
           <a:p>
@@ -3503,7 +3536,7 @@
           </a:p>
           <a:p>
             <a:r>
-              <a:t>Order book (FY24): ₹796.3 Cr</a:t>
+              <a:t>Order book (FY24): ₹470.8 Cr</a:t>
             </a:r>
           </a:p>
         </p:txBody>

</xml_diff>